<commit_message>
update for AI-IoT in Seattle
</commit_message>
<xml_diff>
--- a/Start.pptx
+++ b/Start.pptx
@@ -265,7 +265,7 @@
           <a:p>
             <a:fld id="{EB9EE409-306F-456A-AEE9-92A13D143AD6}" type="datetimeFigureOut">
               <a:rPr lang="en-US" smtClean="0"/>
-              <a:t>1/5/2026</a:t>
+              <a:t>5/20/2026</a:t>
             </a:fld>
             <a:endParaRPr lang="en-US"/>
           </a:p>
@@ -463,7 +463,7 @@
           <a:p>
             <a:fld id="{EB9EE409-306F-456A-AEE9-92A13D143AD6}" type="datetimeFigureOut">
               <a:rPr lang="en-US" smtClean="0"/>
-              <a:t>1/5/2026</a:t>
+              <a:t>5/20/2026</a:t>
             </a:fld>
             <a:endParaRPr lang="en-US"/>
           </a:p>
@@ -671,7 +671,7 @@
           <a:p>
             <a:fld id="{EB9EE409-306F-456A-AEE9-92A13D143AD6}" type="datetimeFigureOut">
               <a:rPr lang="en-US" smtClean="0"/>
-              <a:t>1/5/2026</a:t>
+              <a:t>5/20/2026</a:t>
             </a:fld>
             <a:endParaRPr lang="en-US"/>
           </a:p>
@@ -869,7 +869,7 @@
           <a:p>
             <a:fld id="{EB9EE409-306F-456A-AEE9-92A13D143AD6}" type="datetimeFigureOut">
               <a:rPr lang="en-US" smtClean="0"/>
-              <a:t>1/5/2026</a:t>
+              <a:t>5/20/2026</a:t>
             </a:fld>
             <a:endParaRPr lang="en-US"/>
           </a:p>
@@ -1144,7 +1144,7 @@
           <a:p>
             <a:fld id="{EB9EE409-306F-456A-AEE9-92A13D143AD6}" type="datetimeFigureOut">
               <a:rPr lang="en-US" smtClean="0"/>
-              <a:t>1/5/2026</a:t>
+              <a:t>5/20/2026</a:t>
             </a:fld>
             <a:endParaRPr lang="en-US"/>
           </a:p>
@@ -1409,7 +1409,7 @@
           <a:p>
             <a:fld id="{EB9EE409-306F-456A-AEE9-92A13D143AD6}" type="datetimeFigureOut">
               <a:rPr lang="en-US" smtClean="0"/>
-              <a:t>1/5/2026</a:t>
+              <a:t>5/20/2026</a:t>
             </a:fld>
             <a:endParaRPr lang="en-US"/>
           </a:p>
@@ -1821,7 +1821,7 @@
           <a:p>
             <a:fld id="{EB9EE409-306F-456A-AEE9-92A13D143AD6}" type="datetimeFigureOut">
               <a:rPr lang="en-US" smtClean="0"/>
-              <a:t>1/5/2026</a:t>
+              <a:t>5/20/2026</a:t>
             </a:fld>
             <a:endParaRPr lang="en-US"/>
           </a:p>
@@ -1962,7 +1962,7 @@
           <a:p>
             <a:fld id="{EB9EE409-306F-456A-AEE9-92A13D143AD6}" type="datetimeFigureOut">
               <a:rPr lang="en-US" smtClean="0"/>
-              <a:t>1/5/2026</a:t>
+              <a:t>5/20/2026</a:t>
             </a:fld>
             <a:endParaRPr lang="en-US"/>
           </a:p>
@@ -2075,7 +2075,7 @@
           <a:p>
             <a:fld id="{EB9EE409-306F-456A-AEE9-92A13D143AD6}" type="datetimeFigureOut">
               <a:rPr lang="en-US" smtClean="0"/>
-              <a:t>1/5/2026</a:t>
+              <a:t>5/20/2026</a:t>
             </a:fld>
             <a:endParaRPr lang="en-US"/>
           </a:p>
@@ -2386,7 +2386,7 @@
           <a:p>
             <a:fld id="{EB9EE409-306F-456A-AEE9-92A13D143AD6}" type="datetimeFigureOut">
               <a:rPr lang="en-US" smtClean="0"/>
-              <a:t>1/5/2026</a:t>
+              <a:t>5/20/2026</a:t>
             </a:fld>
             <a:endParaRPr lang="en-US"/>
           </a:p>
@@ -2674,7 +2674,7 @@
           <a:p>
             <a:fld id="{EB9EE409-306F-456A-AEE9-92A13D143AD6}" type="datetimeFigureOut">
               <a:rPr lang="en-US" smtClean="0"/>
-              <a:t>1/5/2026</a:t>
+              <a:t>5/20/2026</a:t>
             </a:fld>
             <a:endParaRPr lang="en-US"/>
           </a:p>
@@ -2915,7 +2915,7 @@
           <a:p>
             <a:fld id="{EB9EE409-306F-456A-AEE9-92A13D143AD6}" type="datetimeFigureOut">
               <a:rPr lang="en-US" smtClean="0"/>
-              <a:t>1/5/2026</a:t>
+              <a:t>5/20/2026</a:t>
             </a:fld>
             <a:endParaRPr lang="en-US"/>
           </a:p>
@@ -3369,10 +3369,7 @@
             <a:br>
               <a:rPr lang="en-US" dirty="0"/>
             </a:br>
-            <a:r>
-              <a:rPr lang="en-US" dirty="0"/>
-              <a:t>CCWC</a:t>
-            </a:r>
+            <a:endParaRPr lang="en-US" dirty="0"/>
           </a:p>
         </p:txBody>
       </p:sp>
@@ -3624,7 +3621,15 @@
             </a:pPr>
             <a:r>
               <a:rPr lang="en-US" dirty="0"/>
-              <a:t>Push it to your own git pages repo</a:t>
+              <a:t>Push it to your own git pages repo (your </a:t>
+            </a:r>
+            <a:r>
+              <a:rPr lang="en-US" dirty="0" err="1"/>
+              <a:t>github</a:t>
+            </a:r>
+            <a:r>
+              <a:rPr lang="en-US" dirty="0"/>
+              <a:t> name)</a:t>
             </a:r>
           </a:p>
           <a:p>
@@ -3777,15 +3782,7 @@
             </a:pPr>
             <a:r>
               <a:rPr lang="en-US" dirty="0"/>
-              <a:t>	</a:t>
-            </a:r>
-            <a:r>
-              <a:rPr lang="en-US" dirty="0" err="1"/>
-              <a:t>goto</a:t>
-            </a:r>
-            <a:r>
-              <a:rPr lang="en-US" dirty="0"/>
-              <a:t> </a:t>
+              <a:t>	Go to  </a:t>
             </a:r>
             <a:r>
               <a:rPr lang="en-US" dirty="0">
@@ -3807,8 +3804,30 @@
             </a:pPr>
             <a:r>
               <a:rPr lang="en-US" dirty="0"/>
-              <a:t>Look at source code </a:t>
-            </a:r>
+              <a:t>Look at source code in </a:t>
+            </a:r>
+          </a:p>
+          <a:p>
+            <a:pPr marL="0" indent="0">
+              <a:buNone/>
+            </a:pPr>
+            <a:r>
+              <a:rPr lang="en-US" dirty="0"/>
+              <a:t>	</a:t>
+            </a:r>
+            <a:r>
+              <a:rPr lang="en-US" dirty="0">
+                <a:hlinkClick r:id="rId3"/>
+              </a:rPr>
+              <a:t>https://github.com/wonder-phil/wonder-phil.github.io</a:t>
+            </a:r>
+            <a:endParaRPr lang="en-US" dirty="0"/>
+          </a:p>
+          <a:p>
+            <a:pPr marL="0" indent="0">
+              <a:buNone/>
+            </a:pPr>
+            <a:endParaRPr lang="en-US" dirty="0"/>
           </a:p>
           <a:p>
             <a:pPr marL="0" indent="0">
@@ -4029,7 +4048,7 @@
                   <a:srgbClr val="FF0000"/>
                 </a:solidFill>
               </a:rPr>
-              <a:t> account</a:t>
+              <a:t> account </a:t>
             </a:r>
           </a:p>
         </p:txBody>
@@ -4319,10 +4338,10 @@
       </p:sp>
       <p:pic>
         <p:nvPicPr>
-          <p:cNvPr id="5" name="Picture 4">
-            <a:extLst>
-              <a:ext uri="{FF2B5EF4-FFF2-40B4-BE49-F238E27FC236}">
-                <a16:creationId xmlns:a16="http://schemas.microsoft.com/office/drawing/2014/main" id="{7AF3DD6B-E9F4-66AB-8E4E-EAB25B84E8F3}"/>
+          <p:cNvPr id="4" name="Picture 3">
+            <a:extLst>
+              <a:ext uri="{FF2B5EF4-FFF2-40B4-BE49-F238E27FC236}">
+                <a16:creationId xmlns:a16="http://schemas.microsoft.com/office/drawing/2014/main" id="{BED00FE3-F5C3-2188-9D32-AAFBDE4E6317}"/>
               </a:ext>
             </a:extLst>
           </p:cNvPr>
@@ -4339,8 +4358,8 @@
         </p:blipFill>
         <p:spPr>
           <a:xfrm>
-            <a:off x="1578212" y="2638332"/>
-            <a:ext cx="8947255" cy="2414681"/>
+            <a:off x="542611" y="2314478"/>
+            <a:ext cx="10840222" cy="2285236"/>
           </a:xfrm>
           <a:prstGeom prst="rect">
             <a:avLst/>

</xml_diff>